<commit_message>
Reframe model comparison: tempo-responsive vs tempo-invariant
- Rename dynamic→tempo-responsive, static→fixed-parameter, add tempo-invariant variant
- Table 2 redesigned: show cost of ignoring tempo (MAPE 12.8% vs 4.6%)
- Section 4.1 rewritten: 'Does incorporating tempo improve projections?'
- IPSS serial downward revision as concrete example
- Abstract, Introduction, Conclusion updated: four contributions
- Cover letter aligned with new framing
- pptx figure captions updated

Co-Authored-By: Tatsuki Onishi <bougtoir@gmail.com>
</commit_message>
<xml_diff>
--- a/tempo-effect-paper/manuscripts/PopStudies_Figures_EN.pptx
+++ b/tempo-effect-paper/manuscripts/PopStudies_Figures_EN.pptx
@@ -3173,7 +3173,7 @@
               <a:defRPr sz="1100" i="1"/>
             </a:pPr>
             <a:r>
-              <a:t>Dynamic model (blue dashed) updates parameters decadally; static model (red dotted) uses 1970 base-year parameters; black solid = UN WPP 2024 observed.</a:t>
+              <a:t>Tempo-responsive model (blue dashed) updates all parameters decadally; fixed-parameter model (red dotted) uses 1970 base-year parameters; black solid = UN WPP 2024 observed.</a:t>
             </a:r>
           </a:p>
         </p:txBody>
@@ -3277,7 +3277,7 @@
               <a:defRPr sz="1100" i="1"/>
             </a:pPr>
             <a:r>
-              <a:t>Dynamic model MAPE shown in upper-right corner of each panel. Countries sorted alphabetically.</a:t>
+              <a:t>Tempo-responsive model MAPE shown in upper-right corner of each panel. Countries sorted alphabetically.</a:t>
             </a:r>
           </a:p>
         </p:txBody>
@@ -3326,7 +3326,7 @@
               <a:defRPr sz="1800" b="1"/>
             </a:pPr>
             <a:r>
-              <a:t>Figure 3: Static model MAPE (%) by country and base year</a:t>
+              <a:t>Figure 3: Fixed-parameter model MAPE (%) by country and base year</a:t>
             </a:r>
           </a:p>
         </p:txBody>
@@ -3430,7 +3430,7 @@
               <a:defRPr sz="1800" b="1"/>
             </a:pPr>
             <a:r>
-              <a:t>Figure 4: Static versus dynamic model comparison</a:t>
+              <a:t>Figure 4: Fixed-parameter versus tempo-responsive model comparison</a:t>
             </a:r>
           </a:p>
         </p:txBody>

</xml_diff>

<commit_message>
Five-model comparison with Bongaarts-Feeney TFR* tempo-adjusted model
Major updates:
- Abstract/Introduction/Results/Discussion/Conclusion rewritten for 5-model frame:
  fixed / tempo-invariant / tempo-responsive / tempo-adjusted (TFR*) / observed
- Table 2 updated with actual WPP-derived values (40 countries, 1970-2023)
- Key insight: period TFR absorbs tempo distortion, making tempo invisible;
  TFR* explicitly decomposes it, yielding best overall fit (median MAPE 4.3%)
- Section 3.3: added TFR* model variant description
- Section 4.1: reframed as 'Why tempo is invisible in standard projections'
- Discussion: four main findings (invisibility, TFR* improvement, magnitude, pace)
- Cover letter updated to match 5-contribution framework
- PPTX figure captions updated for 5-model comparison
- All figures regenerated with 5-model color scheme

Co-Authored-By: Tatsuki Onishi <bougtoir@gmail.com>
</commit_message>
<xml_diff>
--- a/tempo-effect-paper/manuscripts/PopStudies_Figures_EN.pptx
+++ b/tempo-effect-paper/manuscripts/PopStudies_Figures_EN.pptx
@@ -3118,7 +3118,7 @@
               <a:defRPr sz="1800" b="1"/>
             </a:pPr>
             <a:r>
-              <a:t>Figure 1: Model versus observed population trajectories, six representative countries, 1970–2023</a:t>
+              <a:t>Figure 1: Five model variants versus observed population, six representative countries, 1970–2023</a:t>
             </a:r>
           </a:p>
         </p:txBody>
@@ -3173,7 +3173,7 @@
               <a:defRPr sz="1100" i="1"/>
             </a:pPr>
             <a:r>
-              <a:t>Tempo-responsive model (blue dashed) updates all parameters decadally; fixed-parameter model (red dotted) uses 1970 base-year parameters; black solid = UN WPP 2024 observed.</a:t>
+              <a:t>Observed = black solid (UN WPP 2024); Tempo-responsive = blue; Tempo-invariant = orange dashed; Tempo-adjusted (TFR*) = green dash-dot; Fixed-parameter (1970) = red dotted.</a:t>
             </a:r>
           </a:p>
         </p:txBody>
@@ -3222,7 +3222,7 @@
               <a:defRPr sz="1800" b="1"/>
             </a:pPr>
             <a:r>
-              <a:t>Figure 2: Model validation across all 40 countries</a:t>
+              <a:t>Figure 2: Five-model validation across all 40 countries</a:t>
             </a:r>
           </a:p>
         </p:txBody>
@@ -3277,7 +3277,7 @@
               <a:defRPr sz="1100" i="1"/>
             </a:pPr>
             <a:r>
-              <a:t>Tempo-responsive model MAPE shown in upper-right corner of each panel. Countries sorted alphabetically.</a:t>
+              <a:t>Observed = black; Responsive = blue; Invariant = orange; Adjusted (TFR*) = green; Fixed = red. MAPE shown in upper-right corner. Countries sorted alphabetically.</a:t>
             </a:r>
           </a:p>
         </p:txBody>
@@ -3430,7 +3430,7 @@
               <a:defRPr sz="1800" b="1"/>
             </a:pPr>
             <a:r>
-              <a:t>Figure 4: Fixed-parameter versus tempo-responsive model comparison</a:t>
+              <a:t>Figure 4: Four-model comparison — MAPE and final population ratio</a:t>
             </a:r>
           </a:p>
         </p:txBody>
@@ -3451,8 +3451,8 @@
         </p:blipFill>
         <p:spPr>
           <a:xfrm>
-            <a:off x="1523847" y="914400"/>
-            <a:ext cx="9144000" cy="4538292"/>
+            <a:off x="2002446" y="914400"/>
+            <a:ext cx="8186802" cy="4754880"/>
           </a:xfrm>
           <a:prstGeom prst="rect">
             <a:avLst/>
@@ -3485,7 +3485,7 @@
               <a:defRPr sz="1100" i="1"/>
             </a:pPr>
             <a:r>
-              <a:t>Left panel: MAPE by country. Right panel: final population ratio (model/observed in 2023).</a:t>
+              <a:t>Left: MAPE by country for fixed (red), invariant (orange), responsive (blue), adjusted TFR* (green). Right: final ratio (model/observed, 2023). TFR* achieves best overall fit.</a:t>
             </a:r>
           </a:p>
         </p:txBody>

</xml_diff>

<commit_message>
Individual figure files for Population Studies submission
- Regenerated all 5 figures at 300 DPI (T&F color artwork requirement)
- Created figures/submission/ with individual TIFF + JPEG per figure:
  Figure_1.tiff/.jpg: Five model variants showcase (6 countries)
  Figure_2.tiff/.jpg: All 40 countries comparison
  Figure_3.tiff/.jpg: MAPE heatmap by country x base year
  Figure_4.tiff/.jpg: Four-model MAPE and ratio comparison
  Figure_5.tiff/.jpg: Bias analysis (fixed-param, base year 2000)
- TIFF: lossless LZW compression, RGB, 300 DPI (T&F preferred)
- JPEG: quality 95, RGB, 300 DPI (alternative)
- Transparency flattened to white background (T&F requirement)
- Updated run_all.py: all savefig calls now 300 DPI + EPS output

Co-Authored-By: Tatsuki Onishi <bougtoir@gmail.com>
</commit_message>
<xml_diff>
--- a/tempo-effect-paper/manuscripts/PopStudies_Figures_EN.pptx
+++ b/tempo-effect-paper/manuscripts/PopStudies_Figures_EN.pptx
@@ -3139,8 +3139,8 @@
         </p:blipFill>
         <p:spPr>
           <a:xfrm>
-            <a:off x="1813264" y="914400"/>
-            <a:ext cx="8565166" cy="4754880"/>
+            <a:off x="1818845" y="914400"/>
+            <a:ext cx="8554005" cy="4754880"/>
           </a:xfrm>
           <a:prstGeom prst="rect">
             <a:avLst/>
@@ -3243,8 +3243,8 @@
         </p:blipFill>
         <p:spPr>
           <a:xfrm>
-            <a:off x="4239618" y="914400"/>
-            <a:ext cx="3712459" cy="4754880"/>
+            <a:off x="4239381" y="914400"/>
+            <a:ext cx="3712932" cy="4754880"/>
           </a:xfrm>
           <a:prstGeom prst="rect">
             <a:avLst/>
@@ -3347,8 +3347,8 @@
         </p:blipFill>
         <p:spPr>
           <a:xfrm>
-            <a:off x="4646627" y="914400"/>
-            <a:ext cx="2898440" cy="4754880"/>
+            <a:off x="4646955" y="914400"/>
+            <a:ext cx="2897785" cy="4754880"/>
           </a:xfrm>
           <a:prstGeom prst="rect">
             <a:avLst/>
@@ -3451,8 +3451,8 @@
         </p:blipFill>
         <p:spPr>
           <a:xfrm>
-            <a:off x="2002446" y="914400"/>
-            <a:ext cx="8186802" cy="4754880"/>
+            <a:off x="2004665" y="914400"/>
+            <a:ext cx="8182365" cy="4754880"/>
           </a:xfrm>
           <a:prstGeom prst="rect">
             <a:avLst/>
@@ -3556,7 +3556,7 @@
         <p:spPr>
           <a:xfrm>
             <a:off x="1523847" y="914400"/>
-            <a:ext cx="9144000" cy="3021880"/>
+            <a:ext cx="9144000" cy="3029833"/>
           </a:xfrm>
           <a:prstGeom prst="rect">
             <a:avLst/>

</xml_diff>